<commit_message>
Updated packages & documentation for KCDC 2026
</commit_message>
<xml_diff>
--- a/presentation/Accelerating Developer Productivity with.pptx
+++ b/presentation/Accelerating Developer Productivity with.pptx
@@ -117,11 +117,16 @@
       </a:defRPr>
     </a:lvl9pPr>
   </p:defaultTextStyle>
+  <p:extLst>
+    <p:ext uri="{EFAFB233-063F-42B5-8137-9DF3F51BA10A}">
+      <p15:sldGuideLst xmlns:p15="http://schemas.microsoft.com/office/powerpoint/2012/main"/>
+    </p:ext>
+  </p:extLst>
 </p:presentation>
 </file>
 
 <file path=ppt/diagrams/colors1.xml><?xml version="1.0" encoding="utf-8"?>
-<dgm:colorsDef xmlns:dgm="http://schemas.openxmlformats.org/drawingml/2006/diagram" xmlns:a="http://schemas.openxmlformats.org/drawingml/2006/main" uniqueId="urn:microsoft.com/office/officeart/2005/8/colors/colorful5">
+<dgm:colorsDef xmlns:dgm="http://schemas.openxmlformats.org/drawingml/2006/diagram" xmlns:a="http://schemas.openxmlformats.org/drawingml/2006/main" uniqueId="urn:microsoft.com/office/officeart/2005/8/colors/colorful5#1">
   <dgm:title val=""/>
   <dgm:desc val=""/>
   <dgm:catLst>
@@ -903,7 +908,7 @@
 </file>
 
 <file path=ppt/diagrams/colors2.xml><?xml version="1.0" encoding="utf-8"?>
-<dgm:colorsDef xmlns:dgm="http://schemas.openxmlformats.org/drawingml/2006/diagram" xmlns:a="http://schemas.openxmlformats.org/drawingml/2006/main" uniqueId="urn:microsoft.com/office/officeart/2005/8/colors/accent0_3">
+<dgm:colorsDef xmlns:dgm="http://schemas.openxmlformats.org/drawingml/2006/diagram" xmlns:a="http://schemas.openxmlformats.org/drawingml/2006/main" uniqueId="urn:microsoft.com/office/officeart/2005/8/colors/accent0_3#1">
   <dgm:title val=""/>
   <dgm:desc val=""/>
   <dgm:catLst>
@@ -2583,7 +2588,7 @@
 </file>
 
 <file path=ppt/diagrams/colors4.xml><?xml version="1.0" encoding="utf-8"?>
-<dgm:colorsDef xmlns:dgm="http://schemas.openxmlformats.org/drawingml/2006/diagram" xmlns:a="http://schemas.openxmlformats.org/drawingml/2006/main" uniqueId="urn:microsoft.com/office/officeart/2005/8/colors/colorful5">
+<dgm:colorsDef xmlns:dgm="http://schemas.openxmlformats.org/drawingml/2006/diagram" xmlns:a="http://schemas.openxmlformats.org/drawingml/2006/main" uniqueId="urn:microsoft.com/office/officeart/2005/8/colors/colorful5#2">
   <dgm:title val=""/>
   <dgm:desc val=""/>
   <dgm:catLst>
@@ -3365,7 +3370,7 @@
 </file>
 
 <file path=ppt/diagrams/colors5.xml><?xml version="1.0" encoding="utf-8"?>
-<dgm:colorsDef xmlns:dgm="http://schemas.openxmlformats.org/drawingml/2006/diagram" xmlns:a="http://schemas.openxmlformats.org/drawingml/2006/main" uniqueId="urn:microsoft.com/office/officeart/2005/8/colors/colorful2">
+<dgm:colorsDef xmlns:dgm="http://schemas.openxmlformats.org/drawingml/2006/diagram" xmlns:a="http://schemas.openxmlformats.org/drawingml/2006/main" uniqueId="urn:microsoft.com/office/officeart/2005/8/colors/colorful2#1">
   <dgm:title val=""/>
   <dgm:desc val=""/>
   <dgm:catLst>
@@ -4147,7 +4152,7 @@
 </file>
 
 <file path=ppt/diagrams/colors6.xml><?xml version="1.0" encoding="utf-8"?>
-<dgm:colorsDef xmlns:dgm="http://schemas.openxmlformats.org/drawingml/2006/diagram" xmlns:a="http://schemas.openxmlformats.org/drawingml/2006/main" uniqueId="urn:microsoft.com/office/officeart/2005/8/colors/colorful2">
+<dgm:colorsDef xmlns:dgm="http://schemas.openxmlformats.org/drawingml/2006/diagram" xmlns:a="http://schemas.openxmlformats.org/drawingml/2006/main" uniqueId="urn:microsoft.com/office/officeart/2005/8/colors/colorful2#2">
   <dgm:title val=""/>
   <dgm:desc val=""/>
   <dgm:catLst>
@@ -4932,7 +4937,7 @@
 <dgm:dataModel xmlns:dgm="http://schemas.openxmlformats.org/drawingml/2006/diagram" xmlns:a="http://schemas.openxmlformats.org/drawingml/2006/main">
   <dgm:ptLst>
     <dgm:pt modelId="{87BEF23E-9D43-4E1E-8D1D-6AB5FEBBD76A}" type="doc">
-      <dgm:prSet loTypeId="urn:microsoft.com/office/officeart/2005/8/layout/vList2" loCatId="list" qsTypeId="urn:microsoft.com/office/officeart/2005/8/quickstyle/simple1" qsCatId="simple" csTypeId="urn:microsoft.com/office/officeart/2005/8/colors/colorful5" csCatId="colorful"/>
+      <dgm:prSet loTypeId="urn:microsoft.com/office/officeart/2005/8/layout/vList2" loCatId="list" qsTypeId="urn:microsoft.com/office/officeart/2005/8/quickstyle/simple1#1" qsCatId="simple" csTypeId="urn:microsoft.com/office/officeart/2005/8/colors/colorful5#1" csCatId="colorful"/>
       <dgm:spPr/>
       <dgm:t>
         <a:bodyPr/>
@@ -5226,7 +5231,7 @@
 <dgm:dataModel xmlns:dgm="http://schemas.openxmlformats.org/drawingml/2006/diagram" xmlns:a="http://schemas.openxmlformats.org/drawingml/2006/main">
   <dgm:ptLst>
     <dgm:pt modelId="{29CFE1D6-42FB-4179-8783-78EA162F8377}" type="doc">
-      <dgm:prSet loTypeId="urn:microsoft.com/office/officeart/2005/8/layout/matrix3" loCatId="matrix" qsTypeId="urn:microsoft.com/office/officeart/2005/8/quickstyle/simple1" qsCatId="simple" csTypeId="urn:microsoft.com/office/officeart/2005/8/colors/accent0_3" csCatId="mainScheme"/>
+      <dgm:prSet loTypeId="urn:microsoft.com/office/officeart/2005/8/layout/matrix3" loCatId="matrix" qsTypeId="urn:microsoft.com/office/officeart/2005/8/quickstyle/simple1#2" qsCatId="simple" csTypeId="urn:microsoft.com/office/officeart/2005/8/colors/accent0_3#1" csCatId="mainScheme"/>
       <dgm:spPr/>
       <dgm:t>
         <a:bodyPr/>
@@ -5549,7 +5554,7 @@
 <dgm:dataModel xmlns:dgm="http://schemas.openxmlformats.org/drawingml/2006/diagram" xmlns:a="http://schemas.openxmlformats.org/drawingml/2006/main">
   <dgm:ptLst>
     <dgm:pt modelId="{FDB7B126-BC5C-41B1-B575-27B5BB5BC8C2}" type="doc">
-      <dgm:prSet loTypeId="urn:microsoft.com/office/officeart/2018/5/layout/IconCircleLabelList" loCatId="icon" qsTypeId="urn:microsoft.com/office/officeart/2005/8/quickstyle/simple1" qsCatId="simple" csTypeId="urn:microsoft.com/office/officeart/2018/5/colors/Iconchunking_coloredtext_colorful1" csCatId="colorful" phldr="1"/>
+      <dgm:prSet loTypeId="urn:microsoft.com/office/officeart/2018/5/layout/IconCircleLabelList" loCatId="icon" qsTypeId="urn:microsoft.com/office/officeart/2005/8/quickstyle/simple1#3" qsCatId="simple" csTypeId="urn:microsoft.com/office/officeart/2018/5/colors/Iconchunking_coloredtext_colorful1" csCatId="colorful" phldr="1"/>
       <dgm:spPr/>
       <dgm:t>
         <a:bodyPr/>
@@ -5881,7 +5886,7 @@
 <dgm:dataModel xmlns:dgm="http://schemas.openxmlformats.org/drawingml/2006/diagram" xmlns:a="http://schemas.openxmlformats.org/drawingml/2006/main">
   <dgm:ptLst>
     <dgm:pt modelId="{FB028934-01D8-4B42-AF6D-243909422989}" type="doc">
-      <dgm:prSet loTypeId="urn:microsoft.com/office/officeart/2005/8/layout/vList2" loCatId="list" qsTypeId="urn:microsoft.com/office/officeart/2005/8/quickstyle/simple1" qsCatId="simple" csTypeId="urn:microsoft.com/office/officeart/2005/8/colors/colorful5" csCatId="colorful"/>
+      <dgm:prSet loTypeId="urn:microsoft.com/office/officeart/2005/8/layout/vList2" loCatId="list" qsTypeId="urn:microsoft.com/office/officeart/2005/8/quickstyle/simple1#4" qsCatId="simple" csTypeId="urn:microsoft.com/office/officeart/2005/8/colors/colorful5#2" csCatId="colorful"/>
       <dgm:spPr/>
       <dgm:t>
         <a:bodyPr/>
@@ -6125,7 +6130,7 @@
 <dgm:dataModel xmlns:dgm="http://schemas.openxmlformats.org/drawingml/2006/diagram" xmlns:a="http://schemas.openxmlformats.org/drawingml/2006/main">
   <dgm:ptLst>
     <dgm:pt modelId="{BAE0615A-5A9C-4C46-9D45-ECFDFA119444}" type="doc">
-      <dgm:prSet loTypeId="urn:microsoft.com/office/officeart/2005/8/layout/vList2" loCatId="list" qsTypeId="urn:microsoft.com/office/officeart/2005/8/quickstyle/simple1" qsCatId="simple" csTypeId="urn:microsoft.com/office/officeart/2005/8/colors/colorful2" csCatId="colorful"/>
+      <dgm:prSet loTypeId="urn:microsoft.com/office/officeart/2005/8/layout/vList2" loCatId="list" qsTypeId="urn:microsoft.com/office/officeart/2005/8/quickstyle/simple1#5" qsCatId="simple" csTypeId="urn:microsoft.com/office/officeart/2005/8/colors/colorful2#1" csCatId="colorful"/>
       <dgm:spPr/>
       <dgm:t>
         <a:bodyPr/>
@@ -6316,7 +6321,7 @@
 <dgm:dataModel xmlns:dgm="http://schemas.openxmlformats.org/drawingml/2006/diagram" xmlns:a="http://schemas.openxmlformats.org/drawingml/2006/main">
   <dgm:ptLst>
     <dgm:pt modelId="{D17E212D-73AE-44EB-B0C0-7B4EE715DDFA}" type="doc">
-      <dgm:prSet loTypeId="urn:microsoft.com/office/officeart/2016/7/layout/BasicLinearProcessNumbered" loCatId="process" qsTypeId="urn:microsoft.com/office/officeart/2005/8/quickstyle/simple4" qsCatId="simple" csTypeId="urn:microsoft.com/office/officeart/2005/8/colors/colorful2" csCatId="colorful"/>
+      <dgm:prSet loTypeId="urn:microsoft.com/office/officeart/2016/7/layout/BasicLinearProcessNumbered" loCatId="process" qsTypeId="urn:microsoft.com/office/officeart/2005/8/quickstyle/simple4#1" qsCatId="simple" csTypeId="urn:microsoft.com/office/officeart/2005/8/colors/colorful2#2" csCatId="colorful"/>
       <dgm:spPr/>
       <dgm:t>
         <a:bodyPr/>
@@ -10359,7 +10364,7 @@
 </file>
 
 <file path=ppt/diagrams/quickStyle1.xml><?xml version="1.0" encoding="utf-8"?>
-<dgm:styleDef xmlns:dgm="http://schemas.openxmlformats.org/drawingml/2006/diagram" xmlns:a="http://schemas.openxmlformats.org/drawingml/2006/main" uniqueId="urn:microsoft.com/office/officeart/2005/8/quickstyle/simple1">
+<dgm:styleDef xmlns:dgm="http://schemas.openxmlformats.org/drawingml/2006/diagram" xmlns:a="http://schemas.openxmlformats.org/drawingml/2006/main" uniqueId="urn:microsoft.com/office/officeart/2005/8/quickstyle/simple1#1">
   <dgm:title val=""/>
   <dgm:desc val=""/>
   <dgm:catLst>
@@ -11393,7 +11398,7 @@
 </file>
 
 <file path=ppt/diagrams/quickStyle2.xml><?xml version="1.0" encoding="utf-8"?>
-<dgm:styleDef xmlns:dgm="http://schemas.openxmlformats.org/drawingml/2006/diagram" xmlns:a="http://schemas.openxmlformats.org/drawingml/2006/main" uniqueId="urn:microsoft.com/office/officeart/2005/8/quickstyle/simple1">
+<dgm:styleDef xmlns:dgm="http://schemas.openxmlformats.org/drawingml/2006/diagram" xmlns:a="http://schemas.openxmlformats.org/drawingml/2006/main" uniqueId="urn:microsoft.com/office/officeart/2005/8/quickstyle/simple1#2">
   <dgm:title val=""/>
   <dgm:desc val=""/>
   <dgm:catLst>
@@ -12427,7 +12432,7 @@
 </file>
 
 <file path=ppt/diagrams/quickStyle3.xml><?xml version="1.0" encoding="utf-8"?>
-<dgm:styleDef xmlns:dgm="http://schemas.openxmlformats.org/drawingml/2006/diagram" xmlns:a="http://schemas.openxmlformats.org/drawingml/2006/main" uniqueId="urn:microsoft.com/office/officeart/2005/8/quickstyle/simple1">
+<dgm:styleDef xmlns:dgm="http://schemas.openxmlformats.org/drawingml/2006/diagram" xmlns:a="http://schemas.openxmlformats.org/drawingml/2006/main" uniqueId="urn:microsoft.com/office/officeart/2005/8/quickstyle/simple1#3">
   <dgm:title val=""/>
   <dgm:desc val=""/>
   <dgm:catLst>
@@ -13461,7 +13466,7 @@
 </file>
 
 <file path=ppt/diagrams/quickStyle4.xml><?xml version="1.0" encoding="utf-8"?>
-<dgm:styleDef xmlns:dgm="http://schemas.openxmlformats.org/drawingml/2006/diagram" xmlns:a="http://schemas.openxmlformats.org/drawingml/2006/main" uniqueId="urn:microsoft.com/office/officeart/2005/8/quickstyle/simple1">
+<dgm:styleDef xmlns:dgm="http://schemas.openxmlformats.org/drawingml/2006/diagram" xmlns:a="http://schemas.openxmlformats.org/drawingml/2006/main" uniqueId="urn:microsoft.com/office/officeart/2005/8/quickstyle/simple1#4">
   <dgm:title val=""/>
   <dgm:desc val=""/>
   <dgm:catLst>
@@ -14495,7 +14500,7 @@
 </file>
 
 <file path=ppt/diagrams/quickStyle5.xml><?xml version="1.0" encoding="utf-8"?>
-<dgm:styleDef xmlns:dgm="http://schemas.openxmlformats.org/drawingml/2006/diagram" xmlns:a="http://schemas.openxmlformats.org/drawingml/2006/main" uniqueId="urn:microsoft.com/office/officeart/2005/8/quickstyle/simple1">
+<dgm:styleDef xmlns:dgm="http://schemas.openxmlformats.org/drawingml/2006/diagram" xmlns:a="http://schemas.openxmlformats.org/drawingml/2006/main" uniqueId="urn:microsoft.com/office/officeart/2005/8/quickstyle/simple1#5">
   <dgm:title val=""/>
   <dgm:desc val=""/>
   <dgm:catLst>
@@ -15529,7 +15534,7 @@
 </file>
 
 <file path=ppt/diagrams/quickStyle6.xml><?xml version="1.0" encoding="utf-8"?>
-<dgm:styleDef xmlns:dgm="http://schemas.openxmlformats.org/drawingml/2006/diagram" xmlns:a="http://schemas.openxmlformats.org/drawingml/2006/main" uniqueId="urn:microsoft.com/office/officeart/2005/8/quickstyle/simple4">
+<dgm:styleDef xmlns:dgm="http://schemas.openxmlformats.org/drawingml/2006/diagram" xmlns:a="http://schemas.openxmlformats.org/drawingml/2006/main" uniqueId="urn:microsoft.com/office/officeart/2005/8/quickstyle/simple4#1">
   <dgm:title val=""/>
   <dgm:desc val=""/>
   <dgm:catLst>
@@ -16644,7 +16649,7 @@
           <a:p>
             <a:fld id="{79630BB3-2229-47B5-BE03-3AEDCA5B660B}" type="datetimeFigureOut">
               <a:rPr lang="en-US" smtClean="0"/>
-              <a:t>4/10/2026</a:t>
+              <a:t>9/11/2026</a:t>
             </a:fld>
             <a:endParaRPr lang="en-US"/>
           </a:p>
@@ -17145,7 +17150,7 @@
           <a:p>
             <a:fld id="{2732C7D1-21BD-4EBC-AF92-6065CAB56FF9}" type="datetimeFigureOut">
               <a:rPr lang="en-US" smtClean="0"/>
-              <a:t>4/10/2026</a:t>
+              <a:t>9/11/2026</a:t>
             </a:fld>
             <a:endParaRPr lang="en-US"/>
           </a:p>
@@ -17343,7 +17348,7 @@
           <a:p>
             <a:fld id="{2732C7D1-21BD-4EBC-AF92-6065CAB56FF9}" type="datetimeFigureOut">
               <a:rPr lang="en-US" smtClean="0"/>
-              <a:t>4/10/2026</a:t>
+              <a:t>9/11/2026</a:t>
             </a:fld>
             <a:endParaRPr lang="en-US"/>
           </a:p>
@@ -17551,7 +17556,7 @@
           <a:p>
             <a:fld id="{2732C7D1-21BD-4EBC-AF92-6065CAB56FF9}" type="datetimeFigureOut">
               <a:rPr lang="en-US" smtClean="0"/>
-              <a:t>4/10/2026</a:t>
+              <a:t>9/11/2026</a:t>
             </a:fld>
             <a:endParaRPr lang="en-US"/>
           </a:p>
@@ -17749,7 +17754,7 @@
           <a:p>
             <a:fld id="{2732C7D1-21BD-4EBC-AF92-6065CAB56FF9}" type="datetimeFigureOut">
               <a:rPr lang="en-US" smtClean="0"/>
-              <a:t>4/10/2026</a:t>
+              <a:t>9/11/2026</a:t>
             </a:fld>
             <a:endParaRPr lang="en-US"/>
           </a:p>
@@ -18024,7 +18029,7 @@
           <a:p>
             <a:fld id="{2732C7D1-21BD-4EBC-AF92-6065CAB56FF9}" type="datetimeFigureOut">
               <a:rPr lang="en-US" smtClean="0"/>
-              <a:t>4/10/2026</a:t>
+              <a:t>9/11/2026</a:t>
             </a:fld>
             <a:endParaRPr lang="en-US"/>
           </a:p>
@@ -18289,7 +18294,7 @@
           <a:p>
             <a:fld id="{2732C7D1-21BD-4EBC-AF92-6065CAB56FF9}" type="datetimeFigureOut">
               <a:rPr lang="en-US" smtClean="0"/>
-              <a:t>4/10/2026</a:t>
+              <a:t>9/11/2026</a:t>
             </a:fld>
             <a:endParaRPr lang="en-US"/>
           </a:p>
@@ -18701,7 +18706,7 @@
           <a:p>
             <a:fld id="{2732C7D1-21BD-4EBC-AF92-6065CAB56FF9}" type="datetimeFigureOut">
               <a:rPr lang="en-US" smtClean="0"/>
-              <a:t>4/10/2026</a:t>
+              <a:t>9/11/2026</a:t>
             </a:fld>
             <a:endParaRPr lang="en-US"/>
           </a:p>
@@ -18842,7 +18847,7 @@
           <a:p>
             <a:fld id="{2732C7D1-21BD-4EBC-AF92-6065CAB56FF9}" type="datetimeFigureOut">
               <a:rPr lang="en-US" smtClean="0"/>
-              <a:t>4/10/2026</a:t>
+              <a:t>9/11/2026</a:t>
             </a:fld>
             <a:endParaRPr lang="en-US"/>
           </a:p>
@@ -18955,7 +18960,7 @@
           <a:p>
             <a:fld id="{2732C7D1-21BD-4EBC-AF92-6065CAB56FF9}" type="datetimeFigureOut">
               <a:rPr lang="en-US" smtClean="0"/>
-              <a:t>4/10/2026</a:t>
+              <a:t>9/11/2026</a:t>
             </a:fld>
             <a:endParaRPr lang="en-US"/>
           </a:p>
@@ -19266,7 +19271,7 @@
           <a:p>
             <a:fld id="{2732C7D1-21BD-4EBC-AF92-6065CAB56FF9}" type="datetimeFigureOut">
               <a:rPr lang="en-US" smtClean="0"/>
-              <a:t>4/10/2026</a:t>
+              <a:t>9/11/2026</a:t>
             </a:fld>
             <a:endParaRPr lang="en-US"/>
           </a:p>
@@ -19554,7 +19559,7 @@
           <a:p>
             <a:fld id="{2732C7D1-21BD-4EBC-AF92-6065CAB56FF9}" type="datetimeFigureOut">
               <a:rPr lang="en-US" smtClean="0"/>
-              <a:t>4/10/2026</a:t>
+              <a:t>9/11/2026</a:t>
             </a:fld>
             <a:endParaRPr lang="en-US"/>
           </a:p>
@@ -19795,7 +19800,7 @@
           <a:p>
             <a:fld id="{2732C7D1-21BD-4EBC-AF92-6065CAB56FF9}" type="datetimeFigureOut">
               <a:rPr lang="en-US" smtClean="0"/>
-              <a:t>4/10/2026</a:t>
+              <a:t>9/11/2026</a:t>
             </a:fld>
             <a:endParaRPr lang="en-US"/>
           </a:p>
@@ -20310,8 +20315,8 @@
           <a:p>
             <a:pPr algn="l"/>
             <a:r>
-              <a:rPr lang="en-US" sz="4400"/>
-              <a:t>Accelerating Developer Productivity with .NET Aspire</a:t>
+              <a:rPr lang="en-US" sz="4400" dirty="0"/>
+              <a:t>Accelerating Developer Productivity with  Aspire</a:t>
             </a:r>
           </a:p>
         </p:txBody>
@@ -20346,8 +20351,8 @@
           <a:p>
             <a:pPr algn="l"/>
             <a:r>
-              <a:rPr lang="en-US"/>
-              <a:t>Modernizing Existing .NET Projects</a:t>
+              <a:rPr lang="en-US" dirty="0"/>
+              <a:t>Modernizing Existing Projects</a:t>
             </a:r>
           </a:p>
         </p:txBody>
@@ -21510,10 +21515,27 @@
           </a:p>
           <a:p>
             <a:r>
-              <a:rPr lang="en-US"/>
+              <a:rPr lang="en-US" dirty="0"/>
+              <a:t>.NET Templates – </a:t>
+            </a:r>
+          </a:p>
+          <a:p>
+            <a:pPr lvl="1"/>
+            <a:r>
+              <a:rPr lang="en-US" dirty="0"/>
+              <a:t>Dotnet new install </a:t>
+            </a:r>
+            <a:r>
+              <a:rPr lang="en-US" dirty="0" err="1"/>
+              <a:t>Aspire.ProjectTemplates</a:t>
+            </a:r>
+            <a:endParaRPr lang="en-US" dirty="0"/>
+          </a:p>
+          <a:p>
+            <a:r>
+              <a:rPr lang="en-US" dirty="0"/>
               <a:t>My Demo: https://github.com/mitchelsellers/dotnet-aspire-existing-project-demo</a:t>
             </a:r>
-            <a:endParaRPr lang="en-US" dirty="0"/>
           </a:p>
           <a:p>
             <a:endParaRPr lang="en-US" dirty="0"/>
@@ -23415,7 +23437,7 @@
             <a:pPr lvl="2"/>
             <a:r>
               <a:rPr lang="en-US" dirty="0"/>
-              <a:t>Don’t forget about out buddy Claude!</a:t>
+              <a:t>Don’t forget about our buddies Claude/Copilot/ChatGPT!</a:t>
             </a:r>
           </a:p>
           <a:p>

</xml_diff>